<commit_message>
Grafika h7 a h8 podle D. Tyla: test peti sekund, Excel, pravidlo pro AI
Hodina 7: test peti sekund na ukazce B, tri principy (hierarchie,
blizkost a kontrast, poctivy graf) nejdriv otazkou, jedna sada dat
a jeden graf v Excelu (Office 365), Canva volitelne, test u spoluzaka
s pevnymi vetami a oprava. Hodina 8: Urceno pro, vlastni tema uvnitr
variant, pravidlo pro AI, test peti sekund, obhajoby sjednocene
s planem, mereni na ukazce B. Rubrika: kriterium Srozumitelnost.
Hodiny 4 a 5: veta pro koho. Zacni zde: co se zmenilo, popis v bance.

Co-Authored-By: Claude Opus 5.5 <noreply@anthropic.com>
</commit_message>
<xml_diff>
--- a/public/materialy/1L/6/Prezentace k hodinám/7. Infografika a prezentace.pptx
+++ b/public/materialy/1L/6/Prezentace k hodinám/7. Infografika a prezentace.pptx
@@ -513,7 +513,7 @@
           </a:p>
           <a:p>
             <a:r>
-              <a:t>Ověř školní přístup do Canvy a pravidla organizace pro účty nezletilých. Tohle je jediná hodina bloku, která potřebuje přihlášení k externí službě — vyřeš to dřív než v hodině.</a:t>
+              <a:t>Ověř, že se studenti přihlásí školním účtem do Office 365 a mají Excel a PowerPoint. Canva je jen volitelná, hodina na ní nestojí.</a:t>
             </a:r>
           </a:p>
           <a:p>
@@ -521,15 +521,20 @@
               <a:t>Rozbal Výstupy k posouzení.zip a rozdej Infografika v Canvě.txt. Studenti potřebují mít infografiku A i B otevřenou vedle sebe.</a:t>
             </a:r>
           </a:p>
+          <a:p>
+            <a:r>
+              <a:t>Měj ukázku B připravenou na projekci přes celou obrazovku. Hodina začíná testem pěti sekund.</a:t>
+            </a:r>
+          </a:p>
           <a:p/>
           <a:p>
             <a:r>
-              <a:t>KDYŽ CANVA NENÍ</a:t>
-            </a:r>
-          </a:p>
-          <a:p>
-            <a:r>
-              <a:t>Metodika s tím počítá: infografika se navrhne na papír A4 podle stejných kritérií. Hodnotí se rozvržení a poctivost zobrazení, ne ovládání nástroje. Rozbor ukázek A a B proběhne beze změny — je to jen prohlížení obrázků.</a:t>
+              <a:t>KDYŽ POČÍTAČE NEJDOU</a:t>
+            </a:r>
+          </a:p>
+          <a:p>
+            <a:r>
+              <a:t>Infografika se navrhne na papír podle stejných kritérií a test pěti sekund funguje s papírem stejně. Hodnotí se rozvržení, srozumitelnost a poctivost zobrazení, ne ovládání nástroje. Rozbor ukázek A a B proběhne beze změny — je to jen prohlížení obrázků.</a:t>
             </a:r>
           </a:p>
           <a:p/>
@@ -540,7 +545,7 @@
           </a:p>
           <a:p>
             <a:r>
-              <a:t>Student vytvoří infografiku, která data zobrazuje poctivě, a rozpozná zavádějící zobrazení.</a:t>
+              <a:t>Student vytvoří infografiku, která data zobrazuje poctivě a je srozumitelná na první pohled, a rozpozná zavádějící zobrazení.</a:t>
             </a:r>
           </a:p>
           <a:p/>
@@ -551,7 +556,7 @@
           </a:p>
           <a:p>
             <a:r>
-              <a:t>Seznam pěti chyb v ukázce B, vlastní infografika ve dvou formátech a zdůvodnění.</a:t>
+              <a:t>Pět chyb v ukázce B, infografika v PDF a PNG, zápis z testu pěti sekund a co student opravil.</a:t>
             </a:r>
           </a:p>
           <a:p/>
@@ -562,7 +567,7 @@
           </a:p>
           <a:p>
             <a:r>
-              <a:t>5 min porovnání · 7 min výklad · 28 min práce · 5 min rozbor a exit ticket.</a:t>
+              <a:t>5 min test pěti sekund a porovnání · 7 min výklad · 28 min práce · 5 min rozbor a exit ticket.</a:t>
             </a:r>
           </a:p>
         </p:txBody>
@@ -643,13 +648,23 @@
           </a:p>
           <a:p>
             <a:r>
-              <a:t>„Otevřete si obě infografiky ze složky Výstupy k posouzení vedle sebe. Ukazují stejná čísla. Působí opačně. Nejdřív najděte čísla, která jsou v obou stejná — a pak pojmenujte, čím to je.“</a:t>
+              <a:t>„Teď uvidíte jednu infografiku. Jen pět sekund, pak ji schovám. Napište na lísteček jednou větou, co je na ní hlavní.“ Promítni B přes celou obrazovku, odpočítej pět sekund a projekci vypni.</a:t>
+            </a:r>
+          </a:p>
+          <a:p>
+            <a:r>
+              <a:t>Pak: „Otevřete si obě infografiky ze složky Výstupy k posouzení vedle sebe. Ukazují stejná čísla. Působí opačně. Nejdřív najděte čísla, která jsou v obou stejná — a pak pojmenujte, čím to je.“</a:t>
             </a:r>
           </a:p>
           <a:p/>
           <a:p>
             <a:r>
               <a:t>CO DĚLÁŠ</a:t>
+            </a:r>
+          </a:p>
+          <a:p>
+            <a:r>
+              <a:t>Lístečky vyber a po hodině spočítej, kolik studentů napsalo titulek B jako fakt („žáci jsou závislí na mobilech“) a kolik si všimlo, že něco nesedí. Číslo si zapiš. Na konci hodiny 8 test zopakuješ a uvidíš, jestli se něco změnilo.</a:t>
             </a:r>
           </a:p>
           <a:p>
@@ -740,7 +755,7 @@
           <a:lstStyle/>
           <a:p>
             <a:r>
-              <a:t>Čas: 5–12 minut. Promítej u toho ukázku B.</a:t>
+              <a:t>Čas: 5–12 minut. Nejdřív otázka, pojem až potom: snímek s pojmy ukaž, až to třída popíše vlastními slovy.</a:t>
             </a:r>
           </a:p>
           <a:p/>
@@ -751,17 +766,17 @@
           </a:p>
           <a:p>
             <a:r>
-              <a:t>K bodu 01: „Sloupcový graf porovnává výšky. Když osa nezačíná na nule, výšky přestanou odpovídat číslům — z rozdílu tří procent se stane sloupec dvakrát vyšší. Tohle je nejčastější způsob, jak lhát pravdivými čísly.“</a:t>
-            </a:r>
-          </a:p>
-          <a:p>
-            <a:r>
-              <a:t>K bodu 02: „Sloupce jsou na porovnávání množství. Koláč jen na podíly z jednoho celku — a nikdy ve 3D, protože nakloněním se přední výseč opticky zvětší.“</a:t>
-            </a:r>
-          </a:p>
-          <a:p>
-            <a:r>
-              <a:t>K bodu 03: „A poslední věc, na kterou se zapomíná nejčastěji: odkud data jsou, kolika lidí se ptali a kdy. Bez toho není graf informace, ale obrázek.“</a:t>
+              <a:t>K bodu 01: Promítni ukázku A. „Kam jste se podívali nejdřív?“ Nech odpovědět. „Na nadpis. Je největší, je nahoře a říká zjištění, ne jen téma. Tomu se říká hierarchie: co je nejdůležitější, je nejvíc vidět.“</a:t>
+            </a:r>
+          </a:p>
+          <a:p>
+            <a:r>
+              <a:t>K bodu 02: „Jak poznáte, který popisek patří ke kterému grafu? A co na ukázce B křičí nejvíc?“ Pak: „Co je u sebe, čte se jako celek — to je blízkost. A kontrast funguje jen na jedné věci. Když zvýrazníte všechno jako B, nevynikne nic.“</a:t>
+            </a:r>
+          </a:p>
+          <a:p>
+            <a:r>
+              <a:t>K bodu 03: „Sloupcový graf porovnává výšky. Když osa nezačíná na nule, výšky přestanou odpovídat číslům a malý rozdíl vypadá obrovský. Koláč jen na podíly z jednoho celku a nikdy ve 3D, protože nakloněním se přední výseč opticky zvětší. A k číslům patří, odkud jsou, kolika lidí se ptali a kdy.“</a:t>
             </a:r>
           </a:p>
           <a:p>
@@ -789,6 +804,11 @@
           <a:p>
             <a:r>
               <a:t>Neříkej ostatní chyby z ukázky B. Osa stačí jako příklad, zbytek si mají najít.</a:t>
+            </a:r>
+          </a:p>
+          <a:p>
+            <a:r>
+              <a:t>Barvy neprodávej jako psychologická pravidla („červená znamená nebezpečí“). Jak barva působí, záleží na kultuře a souvislostech. Drž se kontrastu a čitelnosti.</a:t>
             </a:r>
           </a:p>
         </p:txBody>
@@ -896,12 +916,12 @@
           </a:p>
           <a:p>
             <a:r>
-              <a:t>Obě sady dat ze zadání, povinné prvky podle pracovního listu.</a:t>
-            </a:r>
-          </a:p>
-          <a:p>
-            <a:r>
-              <a:t>Nejčastější prohřešek studentů je právě ten, který před chvílí kritizovali: Canva useknutou osu nabídne sama a vypadá to líp. Obcházej a kontroluj osy.</a:t>
+              <a:t>Každý si vybere jednu sadu dat, udělá z ní jeden graf v Excelu a vloží ho na snímek v PowerPointu s nadpisem, zdrojem a omezením. Nejdřív ale dvě věty ze zadání: „Určeno pro…“ a „Čtenář má pochopit…“. Bez nich nikoho nepouštěj do Excelu — test pěti sekund by neměl s čím porovnat.</a:t>
+            </a:r>
+          </a:p>
+          <a:p>
+            <a:r>
+              <a:t>Nejčastější prohřešek je právě ten, který před chvílí kritizovali: Excel nabízí 3D grafy a barevné styly a vypadá to líp. Obcházej a kontroluj osy i 3D.</a:t>
             </a:r>
           </a:p>
           <a:p>
@@ -912,12 +932,22 @@
           <a:p/>
           <a:p>
             <a:r>
-              <a:t>34–40 MIN · ZPĚTNÁ VAZBA</a:t>
-            </a:r>
-          </a:p>
-          <a:p>
-            <a:r>
-              <a:t>Promítni dva až tři výstupy a projeď je podle kritérií. Ptej se třídy, ne autora — a začni tím, co je na výstupu dobře.</a:t>
+              <a:t>34–40 MIN · TEST PĚTI SEKUND A OPRAVA</a:t>
+            </a:r>
+          </a:p>
+          <a:p>
+            <a:r>
+              <a:t>Dvojice si vymění obrazovky. Pět sekund dívání, pak autor obrazovku zakryje. Spolužák řekne jen tři věty ze zadání: „Nejdřív jsem se podíval na…“, „Hlavní je podle mě…“, „Nejasné mi bylo…“.</a:t>
+            </a:r>
+          </a:p>
+          <a:p>
+            <a:r>
+              <a:t>Pevné věty nejsou formalita. Bez nich se patnáctiletí shazují nebo chválí naprázdno. Kdo řekne „je to hnusný“ nebo „dobrý“, vrať ho k větám.</a:t>
+            </a:r>
+          </a:p>
+          <a:p>
+            <a:r>
+              <a:t>Autor porovná, co slyšel, se svou větou „Čtenář má pochopit“, opraví jednu věc a zapíše obojí. Pak export do PDF a PNG.</a:t>
             </a:r>
           </a:p>
           <a:p/>
@@ -928,7 +958,7 @@
           </a:p>
           <a:p>
             <a:r>
-              <a:t>Seznam pěti chyb v ukázce B, vlastní infografika ve dvou formátech a zdůvodnění.</a:t>
+              <a:t>Pět chyb v ukázce B, infografika v PDF a PNG, zápis z testu pěti sekund a co student opravil.</a:t>
             </a:r>
           </a:p>
           <a:p/>
@@ -939,7 +969,7 @@
           </a:p>
           <a:p>
             <a:r>
-              <a:t>Zkrať vlastní tvorbu na jednu sadu dat. Rozbor ukázek nekrať, ten nese celou hodinu.</a:t>
+              <a:t>Export ať dodělají doma. Rozbor ukázek ani test pěti sekund nekrať: rozbor nese poctivost, test srozumitelnost.</a:t>
             </a:r>
           </a:p>
         </p:txBody>
@@ -1031,7 +1061,7 @@
           </a:p>
           <a:p>
             <a:r>
-              <a:t>Bod o omezení dat je ten, který skoro nikdo nemá. Řekni k němu příklad: „Ptali jsme se jen naší školy, takže to neplatí o všech středoškolácích.“ Jedna taková věta stačí.</a:t>
+              <a:t>Ve druhém bodě skoro nikdo nemá omezení dat. Řekni k němu příklad: „Ptali jsme se jen naší školy, takže to neplatí o všech středoškolácích.“ Jedna taková věta stačí.</a:t>
             </a:r>
           </a:p>
           <a:p/>
@@ -1128,7 +1158,7 @@
           </a:p>
           <a:p>
             <a:r>
-              <a:t>Nech to chvíli běžet. Dobrý závěr je, že čísla ve sloupcovém grafu B jsou pravdivá a graf přesto klame — useknutá osa a 3D z nich udělají něco jiného, a to se dá udělat i bez úmyslu, protože nástroj to sám nabídne. Jediné vymyšlené číslo je v řádku pod koláčem: „jiné 9 %“ (správně 5 ze 120, tedy asi 4 %), proto součet 104 %.</a:t>
+              <a:t>Nech to chvíli běžet. Dobrý závěr je, že čísla ve sloupcovém grafu B jsou pravdivá a graf přesto klame — useknutá osa a 3D z nich udělají něco jiného, a to se dá udělat i bez úmyslu, protože nástroj to sám nabídne. Jediné vymyšlené číslo je v řádku pod koláčem: „jiné 9 %“ (správně 5 ze 120, tedy asi 4 %), proto součet 104 %.</a:t>
             </a:r>
           </a:p>
           <a:p>
@@ -1154,7 +1184,7 @@
           </a:p>
           <a:p>
             <a:r>
-              <a:t>Součet procent: pokud nedává 100 %, musí být vysvětleno proč.</a:t>
+              <a:t>Na první pohled: co má čtenář pochopit, musí být vidět do pěti sekund. Ověří to test u spolužáka.</a:t>
             </a:r>
           </a:p>
           <a:p>
@@ -4515,7 +4545,7 @@
                 </a:solidFill>
                 <a:latin typeface="Calibri"/>
               </a:rPr>
-              <a:t>Student vytvoří infografiku, která data zobrazuje poctivě, a rozpozná zavádějící zobrazení.</a:t>
+              <a:t>Student vytvoří infografiku, která data zobrazuje poctivě a je srozumitelná na první pohled, a rozpozná zavádějící zobrazení.</a:t>
             </a:r>
           </a:p>
         </p:txBody>
@@ -4949,7 +4979,7 @@
                 </a:solidFill>
                 <a:latin typeface="Calibri"/>
               </a:rPr>
-              <a:t>POROVNEJ A A B</a:t>
+              <a:t>PĚT SEKUND</a:t>
             </a:r>
           </a:p>
         </p:txBody>
@@ -4988,7 +5018,7 @@
                 </a:solidFill>
                 <a:latin typeface="Calibri"/>
               </a:rPr>
-              <a:t>Otevři obě infografiky ze složky Výstupy k posouzení.</a:t>
+              <a:t>Učitel ukáže B na pět sekund. Napiš, co je na ní hlavní.</a:t>
             </a:r>
           </a:p>
         </p:txBody>
@@ -5062,7 +5092,7 @@
                 </a:solidFill>
                 <a:latin typeface="Calibri"/>
               </a:rPr>
-              <a:t>Která čísla jsou v obou stejná?</a:t>
+              <a:t>Otevři A i B. Která čísla jsou v obou stejná?</a:t>
             </a:r>
           </a:p>
         </p:txBody>
@@ -5531,7 +5561,7 @@
                 </a:solidFill>
                 <a:latin typeface="Calibri"/>
               </a:rPr>
-              <a:t>Osa od nuly</a:t>
+              <a:t>Hierarchie</a:t>
             </a:r>
           </a:p>
         </p:txBody>
@@ -5570,7 +5600,7 @@
                 </a:solidFill>
                 <a:latin typeface="Calibri"/>
               </a:rPr>
-              <a:t>Useknutá osa zveličí malý rozdíl. U sloupcového grafu patří nula do grafu.</a:t>
+              <a:t>Kam se podíváš nejdřív? Tam patří hlavní zjištění: největší a nahoře.</a:t>
             </a:r>
           </a:p>
         </p:txBody>
@@ -5684,7 +5714,7 @@
                 </a:solidFill>
                 <a:latin typeface="Calibri"/>
               </a:rPr>
-              <a:t>Graf podle dat</a:t>
+              <a:t>Blízkost a kontrast</a:t>
             </a:r>
           </a:p>
         </p:txBody>
@@ -5723,7 +5753,7 @@
                 </a:solidFill>
                 <a:latin typeface="Calibri"/>
               </a:rPr>
-              <a:t>Sloupce na porovnání množství, koláč jen na podíly z celku a bez 3D.</a:t>
+              <a:t>Co je u sebe, čte se jako celek. Zvýrazni jednu věc, ne všechno.</a:t>
             </a:r>
           </a:p>
         </p:txBody>
@@ -5837,7 +5867,7 @@
                 </a:solidFill>
                 <a:latin typeface="Calibri"/>
               </a:rPr>
-              <a:t>Zdroj a omezení</a:t>
+              <a:t>Poctivý graf</a:t>
             </a:r>
           </a:p>
         </p:txBody>
@@ -5876,7 +5906,7 @@
                 </a:solidFill>
                 <a:latin typeface="Calibri"/>
               </a:rPr>
-              <a:t>Velikost vzorku, datum a původ dat patří k výsledku, ne do poznámky pod čarou.</a:t>
+              <a:t>Osa od nuly, koláč bez 3D. Zdroj, vzorek a datum patří k výsledku.</a:t>
             </a:r>
           </a:p>
         </p:txBody>
@@ -6271,7 +6301,7 @@
                 </a:solidFill>
                 <a:latin typeface="Calibri"/>
               </a:rPr>
-              <a:t>Canva, Infografika v Canvě.txt, Výstupy k posouzení/</a:t>
+              <a:t>Excel, PowerPoint, Infografika v Canvě.txt, Výstupy k posouzení/</a:t>
             </a:r>
           </a:p>
         </p:txBody>
@@ -6341,7 +6371,7 @@
                 </a:solidFill>
                 <a:latin typeface="Calibri"/>
               </a:rPr>
-              <a:t>Rozbor ukázek</a:t>
+              <a:t>Rozbor ukázky B</a:t>
             </a:r>
           </a:p>
         </p:txBody>
@@ -6489,7 +6519,7 @@
                 </a:solidFill>
                 <a:latin typeface="Calibri"/>
               </a:rPr>
-              <a:t>Zpracuj obě sady dat ze zadání podle povinných prvků.</a:t>
+              <a:t>Vyber jednu sadu dat, napiš, pro koho to je, a udělej graf v Excelu.</a:t>
             </a:r>
           </a:p>
         </p:txBody>
@@ -6559,7 +6589,7 @@
                 </a:solidFill>
                 <a:latin typeface="Calibri"/>
               </a:rPr>
-              <a:t>Export</a:t>
+              <a:t>Test pěti sekund</a:t>
             </a:r>
           </a:p>
         </p:txBody>
@@ -6598,7 +6628,7 @@
                 </a:solidFill>
                 <a:latin typeface="Calibri"/>
               </a:rPr>
-              <a:t>Ulož infografika.pdf a infografika.png a zdůvodni volbu formátů.</a:t>
+              <a:t>Spolužák řekne, co je hlavní. Oprav, co nepochopil, a ulož PDF a PNG.</a:t>
             </a:r>
           </a:p>
         </p:txBody>
@@ -6712,7 +6742,7 @@
                 </a:solidFill>
                 <a:latin typeface="Calibri"/>
               </a:rPr>
-              <a:t>Seznam pěti chyb v ukázce B, vlastní infografika ve dvou formátech a zdůvodnění.</a:t>
+              <a:t>Pět chyb v ukázce B, infografika v PDF a PNG, zápis z testu a co jsi opravil.</a:t>
             </a:r>
           </a:p>
         </p:txBody>
@@ -7032,7 +7062,7 @@
                 </a:solidFill>
                 <a:latin typeface="Calibri"/>
               </a:rPr>
-              <a:t>Obě osy v tvé infografice začínají na nule.</a:t>
+              <a:t>Osa tvého grafu začíná na nule a graf není ve 3D.</a:t>
             </a:r>
           </a:p>
         </p:txBody>
@@ -7106,7 +7136,7 @@
                 </a:solidFill>
                 <a:latin typeface="Calibri"/>
               </a:rPr>
-              <a:t>Uvedl jsi zdroj, velikost vzorku i datum.</a:t>
+              <a:t>Uvedl jsi zdroj, velikost vzorku, datum i omezení dat.</a:t>
             </a:r>
           </a:p>
         </p:txBody>
@@ -7180,7 +7210,7 @@
                 </a:solidFill>
                 <a:latin typeface="Calibri"/>
               </a:rPr>
-              <a:t>Máš poznámku o omezení dat.</a:t>
+              <a:t>Použil jsi nejvýše dvě písma a čtyři barvy.</a:t>
             </a:r>
           </a:p>
         </p:txBody>
@@ -7254,7 +7284,7 @@
                 </a:solidFill>
                 <a:latin typeface="Calibri"/>
               </a:rPr>
-              <a:t>Použil jsi nejvýše dvě písma a čtyři barvy.</a:t>
+              <a:t>Po testu pěti sekund jsi opravil, co spolužák nepochopil.</a:t>
             </a:r>
           </a:p>
         </p:txBody>
@@ -7771,7 +7801,7 @@
                 </a:solidFill>
                 <a:latin typeface="Calibri"/>
               </a:rPr>
-              <a:t>Součet procent</a:t>
+              <a:t>Na první pohled</a:t>
             </a:r>
           </a:p>
         </p:txBody>
@@ -7810,7 +7840,7 @@
                 </a:solidFill>
                 <a:latin typeface="Calibri"/>
               </a:rPr>
-              <a:t>Pokud nedává 100 %, musí být vysvětleno proč.</a:t>
+              <a:t>Co má čtenář pochopit, musí být vidět do pěti sekund.</a:t>
             </a:r>
           </a:p>
         </p:txBody>

</xml_diff>